<commit_message>
markdown and ppt addition
</commit_message>
<xml_diff>
--- a/Fullstack.pptx
+++ b/Fullstack.pptx
@@ -14,7 +14,11 @@
     <p:sldId id="258" r:id="rId8"/>
     <p:sldId id="259" r:id="rId9"/>
     <p:sldId id="260" r:id="rId10"/>
-    <p:sldId id="262" r:id="rId11"/>
+    <p:sldId id="266" r:id="rId11"/>
+    <p:sldId id="267" r:id="rId12"/>
+    <p:sldId id="268" r:id="rId13"/>
+    <p:sldId id="269" r:id="rId14"/>
+    <p:sldId id="262" r:id="rId15"/>
   </p:sldIdLst>
   <p:sldSz cx="12192000" cy="6858000"/>
   <p:notesSz cx="6858000" cy="9144000"/>
@@ -268,7 +272,7 @@
           <a:p>
             <a:fld id="{5B5A5958-0E21-4E35-A577-2DB9F9FCF996}" type="datetimeFigureOut">
               <a:rPr lang="en-US" smtClean="0"/>
-              <a:t>3/23/2026</a:t>
+              <a:t>4/29/2026</a:t>
             </a:fld>
             <a:endParaRPr lang="en-US"/>
           </a:p>
@@ -466,7 +470,7 @@
           <a:p>
             <a:fld id="{5B5A5958-0E21-4E35-A577-2DB9F9FCF996}" type="datetimeFigureOut">
               <a:rPr lang="en-US" smtClean="0"/>
-              <a:t>3/23/2026</a:t>
+              <a:t>4/29/2026</a:t>
             </a:fld>
             <a:endParaRPr lang="en-US"/>
           </a:p>
@@ -674,7 +678,7 @@
           <a:p>
             <a:fld id="{5B5A5958-0E21-4E35-A577-2DB9F9FCF996}" type="datetimeFigureOut">
               <a:rPr lang="en-US" smtClean="0"/>
-              <a:t>3/23/2026</a:t>
+              <a:t>4/29/2026</a:t>
             </a:fld>
             <a:endParaRPr lang="en-US"/>
           </a:p>
@@ -872,7 +876,7 @@
           <a:p>
             <a:fld id="{5B5A5958-0E21-4E35-A577-2DB9F9FCF996}" type="datetimeFigureOut">
               <a:rPr lang="en-US" smtClean="0"/>
-              <a:t>3/23/2026</a:t>
+              <a:t>4/29/2026</a:t>
             </a:fld>
             <a:endParaRPr lang="en-US"/>
           </a:p>
@@ -1147,7 +1151,7 @@
           <a:p>
             <a:fld id="{5B5A5958-0E21-4E35-A577-2DB9F9FCF996}" type="datetimeFigureOut">
               <a:rPr lang="en-US" smtClean="0"/>
-              <a:t>3/23/2026</a:t>
+              <a:t>4/29/2026</a:t>
             </a:fld>
             <a:endParaRPr lang="en-US"/>
           </a:p>
@@ -1412,7 +1416,7 @@
           <a:p>
             <a:fld id="{5B5A5958-0E21-4E35-A577-2DB9F9FCF996}" type="datetimeFigureOut">
               <a:rPr lang="en-US" smtClean="0"/>
-              <a:t>3/23/2026</a:t>
+              <a:t>4/29/2026</a:t>
             </a:fld>
             <a:endParaRPr lang="en-US"/>
           </a:p>
@@ -1824,7 +1828,7 @@
           <a:p>
             <a:fld id="{5B5A5958-0E21-4E35-A577-2DB9F9FCF996}" type="datetimeFigureOut">
               <a:rPr lang="en-US" smtClean="0"/>
-              <a:t>3/23/2026</a:t>
+              <a:t>4/29/2026</a:t>
             </a:fld>
             <a:endParaRPr lang="en-US"/>
           </a:p>
@@ -1965,7 +1969,7 @@
           <a:p>
             <a:fld id="{5B5A5958-0E21-4E35-A577-2DB9F9FCF996}" type="datetimeFigureOut">
               <a:rPr lang="en-US" smtClean="0"/>
-              <a:t>3/23/2026</a:t>
+              <a:t>4/29/2026</a:t>
             </a:fld>
             <a:endParaRPr lang="en-US"/>
           </a:p>
@@ -2078,7 +2082,7 @@
           <a:p>
             <a:fld id="{5B5A5958-0E21-4E35-A577-2DB9F9FCF996}" type="datetimeFigureOut">
               <a:rPr lang="en-US" smtClean="0"/>
-              <a:t>3/23/2026</a:t>
+              <a:t>4/29/2026</a:t>
             </a:fld>
             <a:endParaRPr lang="en-US"/>
           </a:p>
@@ -2389,7 +2393,7 @@
           <a:p>
             <a:fld id="{5B5A5958-0E21-4E35-A577-2DB9F9FCF996}" type="datetimeFigureOut">
               <a:rPr lang="en-US" smtClean="0"/>
-              <a:t>3/23/2026</a:t>
+              <a:t>4/29/2026</a:t>
             </a:fld>
             <a:endParaRPr lang="en-US"/>
           </a:p>
@@ -2677,7 +2681,7 @@
           <a:p>
             <a:fld id="{5B5A5958-0E21-4E35-A577-2DB9F9FCF996}" type="datetimeFigureOut">
               <a:rPr lang="en-US" smtClean="0"/>
-              <a:t>3/23/2026</a:t>
+              <a:t>4/29/2026</a:t>
             </a:fld>
             <a:endParaRPr lang="en-US"/>
           </a:p>
@@ -2921,7 +2925,7 @@
           <a:p>
             <a:fld id="{5B5A5958-0E21-4E35-A577-2DB9F9FCF996}" type="datetimeFigureOut">
               <a:rPr lang="en-US" smtClean="0"/>
-              <a:t>3/23/2026</a:t>
+              <a:t>4/29/2026</a:t>
             </a:fld>
             <a:endParaRPr lang="en-US"/>
           </a:p>
@@ -3496,6 +3500,1807 @@
         <p:cNvPr id="1" name="">
           <a:extLst>
             <a:ext uri="{FF2B5EF4-FFF2-40B4-BE49-F238E27FC236}">
+              <a16:creationId xmlns:a16="http://schemas.microsoft.com/office/drawing/2014/main" id="{917F5CBB-692C-3D86-007E-3F08A330EB32}"/>
+            </a:ext>
+          </a:extLst>
+        </p:cNvPr>
+        <p:cNvGrpSpPr/>
+        <p:nvPr/>
+      </p:nvGrpSpPr>
+      <p:grpSpPr>
+        <a:xfrm>
+          <a:off x="0" y="0"/>
+          <a:ext cx="0" cy="0"/>
+          <a:chOff x="0" y="0"/>
+          <a:chExt cx="0" cy="0"/>
+        </a:xfrm>
+      </p:grpSpPr>
+      <p:sp>
+        <p:nvSpPr>
+          <p:cNvPr id="9" name="TextBox 8">
+            <a:extLst>
+              <a:ext uri="{FF2B5EF4-FFF2-40B4-BE49-F238E27FC236}">
+                <a16:creationId xmlns:a16="http://schemas.microsoft.com/office/drawing/2014/main" id="{C024DA0F-9658-4788-464A-6D2ACE5CBB53}"/>
+              </a:ext>
+            </a:extLst>
+          </p:cNvPr>
+          <p:cNvSpPr txBox="1"/>
+          <p:nvPr/>
+        </p:nvSpPr>
+        <p:spPr>
+          <a:xfrm>
+            <a:off x="129985" y="-109728"/>
+            <a:ext cx="3477006" cy="11203067"/>
+          </a:xfrm>
+          <a:prstGeom prst="rect">
+            <a:avLst/>
+          </a:prstGeom>
+          <a:noFill/>
+        </p:spPr>
+        <p:txBody>
+          <a:bodyPr wrap="square">
+            <a:spAutoFit/>
+          </a:bodyPr>
+          <a:lstStyle/>
+          <a:p>
+            <a:endParaRPr lang="hy-AM" sz="2400" dirty="0">
+              <a:solidFill>
+                <a:schemeClr val="bg1"/>
+              </a:solidFill>
+            </a:endParaRPr>
+          </a:p>
+          <a:p>
+            <a:endParaRPr lang="hy-AM" sz="2400" dirty="0">
+              <a:solidFill>
+                <a:schemeClr val="bg1"/>
+              </a:solidFill>
+            </a:endParaRPr>
+          </a:p>
+          <a:p>
+            <a:r>
+              <a:rPr lang="hy-AM" sz="2400" dirty="0">
+                <a:solidFill>
+                  <a:schemeClr val="bg1"/>
+                </a:solidFill>
+              </a:rPr>
+              <a:t>Կայքի հիմնական էջ</a:t>
+            </a:r>
+            <a:br>
+              <a:rPr lang="hy-AM" sz="2000" dirty="0">
+                <a:solidFill>
+                  <a:schemeClr val="bg1"/>
+                </a:solidFill>
+              </a:rPr>
+            </a:br>
+            <a:br>
+              <a:rPr lang="hy-AM" sz="2000" dirty="0">
+                <a:solidFill>
+                  <a:schemeClr val="bg1"/>
+                </a:solidFill>
+              </a:rPr>
+            </a:br>
+            <a:br>
+              <a:rPr lang="hy-AM" dirty="0">
+                <a:solidFill>
+                  <a:schemeClr val="bg1"/>
+                </a:solidFill>
+              </a:rPr>
+            </a:br>
+            <a:br>
+              <a:rPr lang="hy-AM" dirty="0">
+                <a:solidFill>
+                  <a:schemeClr val="bg1"/>
+                </a:solidFill>
+              </a:rPr>
+            </a:br>
+            <a:endParaRPr lang="hy-AM" dirty="0">
+              <a:solidFill>
+                <a:schemeClr val="bg1"/>
+              </a:solidFill>
+            </a:endParaRPr>
+          </a:p>
+          <a:p>
+            <a:endParaRPr lang="hy-AM" dirty="0">
+              <a:solidFill>
+                <a:schemeClr val="bg1"/>
+              </a:solidFill>
+            </a:endParaRPr>
+          </a:p>
+          <a:p>
+            <a:br>
+              <a:rPr lang="hy-AM" dirty="0">
+                <a:solidFill>
+                  <a:schemeClr val="bg1"/>
+                </a:solidFill>
+              </a:rPr>
+            </a:br>
+            <a:r>
+              <a:rPr lang="hy-AM" dirty="0">
+                <a:solidFill>
+                  <a:schemeClr val="bg1"/>
+                </a:solidFill>
+              </a:rPr>
+              <a:t>•</a:t>
+            </a:r>
+            <a:r>
+              <a:rPr lang="en-US" dirty="0">
+                <a:solidFill>
+                  <a:schemeClr val="bg1"/>
+                </a:solidFill>
+              </a:rPr>
+              <a:t> </a:t>
+            </a:r>
+            <a:r>
+              <a:rPr lang="hy-AM" dirty="0">
+                <a:solidFill>
+                  <a:schemeClr val="bg1"/>
+                </a:solidFill>
+              </a:rPr>
+              <a:t>Որոնման համակարգ</a:t>
+            </a:r>
+            <a:br>
+              <a:rPr lang="hy-AM" dirty="0">
+                <a:solidFill>
+                  <a:schemeClr val="bg1"/>
+                </a:solidFill>
+              </a:rPr>
+            </a:br>
+            <a:br>
+              <a:rPr lang="hy-AM" dirty="0">
+                <a:solidFill>
+                  <a:schemeClr val="bg1"/>
+                </a:solidFill>
+              </a:rPr>
+            </a:br>
+            <a:r>
+              <a:rPr lang="hy-AM" dirty="0">
+                <a:solidFill>
+                  <a:schemeClr val="bg1"/>
+                </a:solidFill>
+              </a:rPr>
+              <a:t>•</a:t>
+            </a:r>
+            <a:r>
+              <a:rPr lang="en-US" dirty="0">
+                <a:solidFill>
+                  <a:schemeClr val="bg1"/>
+                </a:solidFill>
+              </a:rPr>
+              <a:t> </a:t>
+            </a:r>
+            <a:r>
+              <a:rPr lang="hy-AM" dirty="0">
+                <a:solidFill>
+                  <a:schemeClr val="bg1"/>
+                </a:solidFill>
+              </a:rPr>
+              <a:t>Ֆիլտրեր</a:t>
+            </a:r>
+            <a:br>
+              <a:rPr lang="hy-AM" dirty="0">
+                <a:solidFill>
+                  <a:schemeClr val="bg1"/>
+                </a:solidFill>
+              </a:rPr>
+            </a:br>
+            <a:br>
+              <a:rPr lang="hy-AM" dirty="0">
+                <a:solidFill>
+                  <a:schemeClr val="bg1"/>
+                </a:solidFill>
+              </a:rPr>
+            </a:br>
+            <a:r>
+              <a:rPr lang="hy-AM" dirty="0">
+                <a:solidFill>
+                  <a:schemeClr val="bg1"/>
+                </a:solidFill>
+              </a:rPr>
+              <a:t>•</a:t>
+            </a:r>
+            <a:r>
+              <a:rPr lang="en-US" dirty="0">
+                <a:solidFill>
+                  <a:schemeClr val="bg1"/>
+                </a:solidFill>
+              </a:rPr>
+              <a:t> </a:t>
+            </a:r>
+            <a:r>
+              <a:rPr lang="hy-AM" dirty="0">
+                <a:solidFill>
+                  <a:schemeClr val="bg1"/>
+                </a:solidFill>
+              </a:rPr>
+              <a:t>Ավտոմեքենաների </a:t>
+            </a:r>
+          </a:p>
+          <a:p>
+            <a:r>
+              <a:rPr lang="hy-AM" dirty="0">
+                <a:solidFill>
+                  <a:schemeClr val="bg1"/>
+                </a:solidFill>
+              </a:rPr>
+              <a:t>հայտարարություններ</a:t>
+            </a:r>
+            <a:br>
+              <a:rPr lang="hy-AM" dirty="0">
+                <a:solidFill>
+                  <a:schemeClr val="bg1"/>
+                </a:solidFill>
+              </a:rPr>
+            </a:br>
+            <a:br>
+              <a:rPr lang="hy-AM" dirty="0">
+                <a:solidFill>
+                  <a:schemeClr val="bg1"/>
+                </a:solidFill>
+              </a:rPr>
+            </a:br>
+            <a:r>
+              <a:rPr lang="hy-AM" dirty="0">
+                <a:solidFill>
+                  <a:schemeClr val="bg1"/>
+                </a:solidFill>
+              </a:rPr>
+              <a:t>•</a:t>
+            </a:r>
+            <a:r>
+              <a:rPr lang="en-US" dirty="0">
+                <a:solidFill>
+                  <a:schemeClr val="bg1"/>
+                </a:solidFill>
+              </a:rPr>
+              <a:t> </a:t>
+            </a:r>
+            <a:r>
+              <a:rPr lang="hy-AM" dirty="0">
+                <a:solidFill>
+                  <a:schemeClr val="bg1"/>
+                </a:solidFill>
+              </a:rPr>
+              <a:t>Անձնական էջի վահանակ</a:t>
+            </a:r>
+            <a:br>
+              <a:rPr lang="hy-AM" dirty="0">
+                <a:solidFill>
+                  <a:schemeClr val="bg1"/>
+                </a:solidFill>
+              </a:rPr>
+            </a:br>
+            <a:br>
+              <a:rPr lang="hy-AM" dirty="0">
+                <a:solidFill>
+                  <a:schemeClr val="bg1"/>
+                </a:solidFill>
+              </a:rPr>
+            </a:br>
+            <a:r>
+              <a:rPr lang="hy-AM" dirty="0">
+                <a:solidFill>
+                  <a:schemeClr val="bg1"/>
+                </a:solidFill>
+              </a:rPr>
+              <a:t>•</a:t>
+            </a:r>
+            <a:r>
+              <a:rPr lang="en-US" dirty="0">
+                <a:solidFill>
+                  <a:schemeClr val="bg1"/>
+                </a:solidFill>
+              </a:rPr>
+              <a:t> </a:t>
+            </a:r>
+            <a:r>
+              <a:rPr lang="hy-AM" dirty="0">
+                <a:solidFill>
+                  <a:schemeClr val="bg1"/>
+                </a:solidFill>
+              </a:rPr>
+              <a:t>Ուղարկված հայցերի վահանակ</a:t>
+            </a:r>
+          </a:p>
+          <a:p>
+            <a:endParaRPr lang="hy-AM" dirty="0">
+              <a:solidFill>
+                <a:schemeClr val="bg1"/>
+              </a:solidFill>
+            </a:endParaRPr>
+          </a:p>
+          <a:p>
+            <a:endParaRPr lang="hy-AM" dirty="0">
+              <a:solidFill>
+                <a:schemeClr val="bg1"/>
+              </a:solidFill>
+            </a:endParaRPr>
+          </a:p>
+          <a:p>
+            <a:endParaRPr lang="hy-AM" dirty="0">
+              <a:solidFill>
+                <a:schemeClr val="bg1"/>
+              </a:solidFill>
+            </a:endParaRPr>
+          </a:p>
+          <a:p>
+            <a:endParaRPr lang="hy-AM" dirty="0">
+              <a:solidFill>
+                <a:schemeClr val="bg1"/>
+              </a:solidFill>
+            </a:endParaRPr>
+          </a:p>
+          <a:p>
+            <a:endParaRPr lang="hy-AM" dirty="0">
+              <a:solidFill>
+                <a:schemeClr val="bg1"/>
+              </a:solidFill>
+            </a:endParaRPr>
+          </a:p>
+          <a:p>
+            <a:endParaRPr lang="hy-AM" dirty="0">
+              <a:solidFill>
+                <a:schemeClr val="bg1"/>
+              </a:solidFill>
+            </a:endParaRPr>
+          </a:p>
+          <a:p>
+            <a:endParaRPr lang="hy-AM" dirty="0">
+              <a:solidFill>
+                <a:schemeClr val="bg1"/>
+              </a:solidFill>
+            </a:endParaRPr>
+          </a:p>
+          <a:p>
+            <a:endParaRPr lang="hy-AM" dirty="0">
+              <a:solidFill>
+                <a:schemeClr val="bg1"/>
+              </a:solidFill>
+            </a:endParaRPr>
+          </a:p>
+          <a:p>
+            <a:endParaRPr lang="hy-AM" dirty="0">
+              <a:solidFill>
+                <a:schemeClr val="bg1"/>
+              </a:solidFill>
+            </a:endParaRPr>
+          </a:p>
+          <a:p>
+            <a:endParaRPr lang="hy-AM" dirty="0">
+              <a:solidFill>
+                <a:schemeClr val="bg1"/>
+              </a:solidFill>
+            </a:endParaRPr>
+          </a:p>
+          <a:p>
+            <a:endParaRPr lang="hy-AM" dirty="0">
+              <a:solidFill>
+                <a:schemeClr val="bg1"/>
+              </a:solidFill>
+            </a:endParaRPr>
+          </a:p>
+          <a:p>
+            <a:endParaRPr lang="hy-AM" dirty="0">
+              <a:solidFill>
+                <a:schemeClr val="bg1"/>
+              </a:solidFill>
+            </a:endParaRPr>
+          </a:p>
+          <a:p>
+            <a:endParaRPr lang="hy-AM" dirty="0">
+              <a:solidFill>
+                <a:schemeClr val="bg1"/>
+              </a:solidFill>
+            </a:endParaRPr>
+          </a:p>
+          <a:p>
+            <a:endParaRPr lang="hy-AM" dirty="0">
+              <a:solidFill>
+                <a:schemeClr val="bg1"/>
+              </a:solidFill>
+            </a:endParaRPr>
+          </a:p>
+          <a:p>
+            <a:endParaRPr lang="hy-AM" dirty="0">
+              <a:solidFill>
+                <a:schemeClr val="bg1"/>
+              </a:solidFill>
+            </a:endParaRPr>
+          </a:p>
+          <a:p>
+            <a:endParaRPr lang="hy-AM" dirty="0">
+              <a:solidFill>
+                <a:schemeClr val="bg1"/>
+              </a:solidFill>
+            </a:endParaRPr>
+          </a:p>
+          <a:p>
+            <a:endParaRPr lang="hy-AM" dirty="0">
+              <a:solidFill>
+                <a:schemeClr val="bg1"/>
+              </a:solidFill>
+            </a:endParaRPr>
+          </a:p>
+          <a:p>
+            <a:endParaRPr lang="hy-AM" dirty="0">
+              <a:solidFill>
+                <a:schemeClr val="bg1"/>
+              </a:solidFill>
+            </a:endParaRPr>
+          </a:p>
+          <a:p>
+            <a:endParaRPr lang="en-US" dirty="0">
+              <a:solidFill>
+                <a:schemeClr val="bg1"/>
+              </a:solidFill>
+            </a:endParaRPr>
+          </a:p>
+        </p:txBody>
+      </p:sp>
+      <p:pic>
+        <p:nvPicPr>
+          <p:cNvPr id="3" name="Picture 2">
+            <a:extLst>
+              <a:ext uri="{FF2B5EF4-FFF2-40B4-BE49-F238E27FC236}">
+                <a16:creationId xmlns:a16="http://schemas.microsoft.com/office/drawing/2014/main" id="{3AF134B9-6B5E-F8F9-DDA0-E0A4C8355BA6}"/>
+              </a:ext>
+            </a:extLst>
+          </p:cNvPr>
+          <p:cNvPicPr>
+            <a:picLocks noChangeAspect="1"/>
+          </p:cNvPicPr>
+          <p:nvPr/>
+        </p:nvPicPr>
+        <p:blipFill>
+          <a:blip r:embed="rId2"/>
+          <a:stretch>
+            <a:fillRect/>
+          </a:stretch>
+        </p:blipFill>
+        <p:spPr>
+          <a:xfrm>
+            <a:off x="3689287" y="0"/>
+            <a:ext cx="8502713" cy="6858000"/>
+          </a:xfrm>
+          <a:prstGeom prst="rect">
+            <a:avLst/>
+          </a:prstGeom>
+        </p:spPr>
+      </p:pic>
+    </p:spTree>
+    <p:extLst>
+      <p:ext uri="{BB962C8B-B14F-4D97-AF65-F5344CB8AC3E}">
+        <p14:creationId xmlns:p14="http://schemas.microsoft.com/office/powerpoint/2010/main" val="324386563"/>
+      </p:ext>
+    </p:extLst>
+  </p:cSld>
+  <p:clrMapOvr>
+    <a:masterClrMapping/>
+  </p:clrMapOvr>
+</p:sld>
+</file>
+
+<file path=ppt/slides/slide11.xml><?xml version="1.0" encoding="utf-8"?>
+<p:sld xmlns:a="http://schemas.openxmlformats.org/drawingml/2006/main" xmlns:r="http://schemas.openxmlformats.org/officeDocument/2006/relationships" xmlns:p="http://schemas.openxmlformats.org/presentationml/2006/main">
+  <p:cSld>
+    <p:spTree>
+      <p:nvGrpSpPr>
+        <p:cNvPr id="1" name="">
+          <a:extLst>
+            <a:ext uri="{FF2B5EF4-FFF2-40B4-BE49-F238E27FC236}">
+              <a16:creationId xmlns:a16="http://schemas.microsoft.com/office/drawing/2014/main" id="{54E43A09-A28E-B0BA-2135-1F64016F8584}"/>
+            </a:ext>
+          </a:extLst>
+        </p:cNvPr>
+        <p:cNvGrpSpPr/>
+        <p:nvPr/>
+      </p:nvGrpSpPr>
+      <p:grpSpPr>
+        <a:xfrm>
+          <a:off x="0" y="0"/>
+          <a:ext cx="0" cy="0"/>
+          <a:chOff x="0" y="0"/>
+          <a:chExt cx="0" cy="0"/>
+        </a:xfrm>
+      </p:grpSpPr>
+      <p:sp>
+        <p:nvSpPr>
+          <p:cNvPr id="9" name="TextBox 8">
+            <a:extLst>
+              <a:ext uri="{FF2B5EF4-FFF2-40B4-BE49-F238E27FC236}">
+                <a16:creationId xmlns:a16="http://schemas.microsoft.com/office/drawing/2014/main" id="{AF0404C9-0EB5-3204-ED07-B5452B125D40}"/>
+              </a:ext>
+            </a:extLst>
+          </p:cNvPr>
+          <p:cNvSpPr txBox="1"/>
+          <p:nvPr/>
+        </p:nvSpPr>
+        <p:spPr>
+          <a:xfrm>
+            <a:off x="70866" y="516128"/>
+            <a:ext cx="5255839" cy="9848850"/>
+          </a:xfrm>
+          <a:prstGeom prst="rect">
+            <a:avLst/>
+          </a:prstGeom>
+          <a:noFill/>
+        </p:spPr>
+        <p:txBody>
+          <a:bodyPr wrap="square">
+            <a:spAutoFit/>
+          </a:bodyPr>
+          <a:lstStyle/>
+          <a:p>
+            <a:r>
+              <a:rPr lang="hy-AM" sz="2000" dirty="0">
+                <a:solidFill>
+                  <a:schemeClr val="bg1"/>
+                </a:solidFill>
+              </a:rPr>
+              <a:t>Ավտոմեքենայի հայտարարության էջ</a:t>
+            </a:r>
+            <a:br>
+              <a:rPr lang="hy-AM" sz="2000" dirty="0">
+                <a:solidFill>
+                  <a:schemeClr val="bg1"/>
+                </a:solidFill>
+              </a:rPr>
+            </a:br>
+            <a:br>
+              <a:rPr lang="hy-AM" sz="2000" dirty="0">
+                <a:solidFill>
+                  <a:schemeClr val="bg1"/>
+                </a:solidFill>
+              </a:rPr>
+            </a:br>
+            <a:br>
+              <a:rPr lang="hy-AM" dirty="0">
+                <a:solidFill>
+                  <a:schemeClr val="bg1"/>
+                </a:solidFill>
+              </a:rPr>
+            </a:br>
+            <a:br>
+              <a:rPr lang="hy-AM" dirty="0">
+                <a:solidFill>
+                  <a:schemeClr val="bg1"/>
+                </a:solidFill>
+              </a:rPr>
+            </a:br>
+            <a:br>
+              <a:rPr lang="hy-AM" dirty="0">
+                <a:solidFill>
+                  <a:schemeClr val="bg1"/>
+                </a:solidFill>
+              </a:rPr>
+            </a:br>
+            <a:br>
+              <a:rPr lang="hy-AM" dirty="0">
+                <a:solidFill>
+                  <a:schemeClr val="bg1"/>
+                </a:solidFill>
+              </a:rPr>
+            </a:br>
+            <a:r>
+              <a:rPr lang="en-US" dirty="0">
+                <a:solidFill>
+                  <a:schemeClr val="bg1"/>
+                </a:solidFill>
+              </a:rPr>
+              <a:t>• </a:t>
+            </a:r>
+            <a:r>
+              <a:rPr lang="hy-AM" dirty="0">
+                <a:solidFill>
+                  <a:schemeClr val="bg1"/>
+                </a:solidFill>
+              </a:rPr>
+              <a:t>Վաճառողի մասին ինֆորմացիա</a:t>
+            </a:r>
+          </a:p>
+          <a:p>
+            <a:endParaRPr lang="hy-AM" dirty="0">
+              <a:solidFill>
+                <a:schemeClr val="bg1"/>
+              </a:solidFill>
+            </a:endParaRPr>
+          </a:p>
+          <a:p>
+            <a:r>
+              <a:rPr lang="en-US" dirty="0">
+                <a:solidFill>
+                  <a:schemeClr val="bg1"/>
+                </a:solidFill>
+              </a:rPr>
+              <a:t>• </a:t>
+            </a:r>
+            <a:r>
+              <a:rPr lang="hy-AM" dirty="0">
+                <a:solidFill>
+                  <a:schemeClr val="bg1"/>
+                </a:solidFill>
+              </a:rPr>
+              <a:t>Ավտոմեքենայի պարամետրերը</a:t>
+            </a:r>
+          </a:p>
+          <a:p>
+            <a:endParaRPr lang="hy-AM" dirty="0">
+              <a:solidFill>
+                <a:schemeClr val="bg1"/>
+              </a:solidFill>
+            </a:endParaRPr>
+          </a:p>
+          <a:p>
+            <a:r>
+              <a:rPr lang="en-US" dirty="0">
+                <a:solidFill>
+                  <a:schemeClr val="bg1"/>
+                </a:solidFill>
+              </a:rPr>
+              <a:t>•</a:t>
+            </a:r>
+            <a:r>
+              <a:rPr lang="hy-AM" dirty="0">
+                <a:solidFill>
+                  <a:schemeClr val="bg1"/>
+                </a:solidFill>
+              </a:rPr>
+              <a:t> Նկարագրությունը</a:t>
+            </a:r>
+            <a:br>
+              <a:rPr lang="hy-AM" dirty="0">
+                <a:solidFill>
+                  <a:schemeClr val="bg1"/>
+                </a:solidFill>
+              </a:rPr>
+            </a:br>
+            <a:br>
+              <a:rPr lang="hy-AM" dirty="0">
+                <a:solidFill>
+                  <a:schemeClr val="bg1"/>
+                </a:solidFill>
+              </a:rPr>
+            </a:br>
+            <a:r>
+              <a:rPr lang="en-US" dirty="0">
+                <a:solidFill>
+                  <a:schemeClr val="bg1"/>
+                </a:solidFill>
+              </a:rPr>
+              <a:t>•</a:t>
+            </a:r>
+            <a:r>
+              <a:rPr lang="hy-AM" dirty="0">
+                <a:solidFill>
+                  <a:schemeClr val="bg1"/>
+                </a:solidFill>
+              </a:rPr>
+              <a:t> Այլ հայտարարություններ նույն վաճառողից</a:t>
+            </a:r>
+          </a:p>
+          <a:p>
+            <a:endParaRPr lang="hy-AM" dirty="0">
+              <a:solidFill>
+                <a:schemeClr val="bg1"/>
+              </a:solidFill>
+            </a:endParaRPr>
+          </a:p>
+          <a:p>
+            <a:r>
+              <a:rPr lang="en-US" dirty="0">
+                <a:solidFill>
+                  <a:schemeClr val="bg1"/>
+                </a:solidFill>
+              </a:rPr>
+              <a:t>•</a:t>
+            </a:r>
+            <a:r>
+              <a:rPr lang="hy-AM" dirty="0">
+                <a:solidFill>
+                  <a:schemeClr val="bg1"/>
+                </a:solidFill>
+              </a:rPr>
+              <a:t> Գնելու հայց ուղարկելու հնարավորություն</a:t>
+            </a:r>
+            <a:br>
+              <a:rPr lang="hy-AM" dirty="0">
+                <a:solidFill>
+                  <a:schemeClr val="bg1"/>
+                </a:solidFill>
+              </a:rPr>
+            </a:br>
+            <a:br>
+              <a:rPr lang="hy-AM" dirty="0">
+                <a:solidFill>
+                  <a:schemeClr val="bg1"/>
+                </a:solidFill>
+              </a:rPr>
+            </a:br>
+            <a:endParaRPr lang="hy-AM" dirty="0">
+              <a:solidFill>
+                <a:schemeClr val="bg1"/>
+              </a:solidFill>
+            </a:endParaRPr>
+          </a:p>
+          <a:p>
+            <a:endParaRPr lang="hy-AM" dirty="0">
+              <a:solidFill>
+                <a:schemeClr val="bg1"/>
+              </a:solidFill>
+            </a:endParaRPr>
+          </a:p>
+          <a:p>
+            <a:endParaRPr lang="hy-AM" dirty="0">
+              <a:solidFill>
+                <a:schemeClr val="bg1"/>
+              </a:solidFill>
+            </a:endParaRPr>
+          </a:p>
+          <a:p>
+            <a:endParaRPr lang="hy-AM" dirty="0">
+              <a:solidFill>
+                <a:schemeClr val="bg1"/>
+              </a:solidFill>
+            </a:endParaRPr>
+          </a:p>
+          <a:p>
+            <a:endParaRPr lang="hy-AM" dirty="0">
+              <a:solidFill>
+                <a:schemeClr val="bg1"/>
+              </a:solidFill>
+            </a:endParaRPr>
+          </a:p>
+          <a:p>
+            <a:endParaRPr lang="hy-AM" dirty="0">
+              <a:solidFill>
+                <a:schemeClr val="bg1"/>
+              </a:solidFill>
+            </a:endParaRPr>
+          </a:p>
+          <a:p>
+            <a:endParaRPr lang="hy-AM" dirty="0">
+              <a:solidFill>
+                <a:schemeClr val="bg1"/>
+              </a:solidFill>
+            </a:endParaRPr>
+          </a:p>
+          <a:p>
+            <a:endParaRPr lang="hy-AM" dirty="0">
+              <a:solidFill>
+                <a:schemeClr val="bg1"/>
+              </a:solidFill>
+            </a:endParaRPr>
+          </a:p>
+          <a:p>
+            <a:endParaRPr lang="hy-AM" dirty="0">
+              <a:solidFill>
+                <a:schemeClr val="bg1"/>
+              </a:solidFill>
+            </a:endParaRPr>
+          </a:p>
+          <a:p>
+            <a:endParaRPr lang="hy-AM" dirty="0">
+              <a:solidFill>
+                <a:schemeClr val="bg1"/>
+              </a:solidFill>
+            </a:endParaRPr>
+          </a:p>
+          <a:p>
+            <a:endParaRPr lang="hy-AM" dirty="0">
+              <a:solidFill>
+                <a:schemeClr val="bg1"/>
+              </a:solidFill>
+            </a:endParaRPr>
+          </a:p>
+          <a:p>
+            <a:endParaRPr lang="hy-AM" dirty="0">
+              <a:solidFill>
+                <a:schemeClr val="bg1"/>
+              </a:solidFill>
+            </a:endParaRPr>
+          </a:p>
+          <a:p>
+            <a:endParaRPr lang="hy-AM" dirty="0">
+              <a:solidFill>
+                <a:schemeClr val="bg1"/>
+              </a:solidFill>
+            </a:endParaRPr>
+          </a:p>
+          <a:p>
+            <a:endParaRPr lang="hy-AM" dirty="0">
+              <a:solidFill>
+                <a:schemeClr val="bg1"/>
+              </a:solidFill>
+            </a:endParaRPr>
+          </a:p>
+          <a:p>
+            <a:endParaRPr lang="hy-AM" dirty="0">
+              <a:solidFill>
+                <a:schemeClr val="bg1"/>
+              </a:solidFill>
+            </a:endParaRPr>
+          </a:p>
+          <a:p>
+            <a:endParaRPr lang="hy-AM" dirty="0">
+              <a:solidFill>
+                <a:schemeClr val="bg1"/>
+              </a:solidFill>
+            </a:endParaRPr>
+          </a:p>
+          <a:p>
+            <a:endParaRPr lang="hy-AM" dirty="0">
+              <a:solidFill>
+                <a:schemeClr val="bg1"/>
+              </a:solidFill>
+            </a:endParaRPr>
+          </a:p>
+          <a:p>
+            <a:endParaRPr lang="hy-AM" dirty="0">
+              <a:solidFill>
+                <a:schemeClr val="bg1"/>
+              </a:solidFill>
+            </a:endParaRPr>
+          </a:p>
+          <a:p>
+            <a:endParaRPr lang="en-US" dirty="0">
+              <a:solidFill>
+                <a:schemeClr val="bg1"/>
+              </a:solidFill>
+            </a:endParaRPr>
+          </a:p>
+        </p:txBody>
+      </p:sp>
+      <p:pic>
+        <p:nvPicPr>
+          <p:cNvPr id="4" name="Picture 3">
+            <a:extLst>
+              <a:ext uri="{FF2B5EF4-FFF2-40B4-BE49-F238E27FC236}">
+                <a16:creationId xmlns:a16="http://schemas.microsoft.com/office/drawing/2014/main" id="{C2809A5A-080C-BF02-F64B-E4091ED7ECE4}"/>
+              </a:ext>
+            </a:extLst>
+          </p:cNvPr>
+          <p:cNvPicPr>
+            <a:picLocks noChangeAspect="1"/>
+          </p:cNvPicPr>
+          <p:nvPr/>
+        </p:nvPicPr>
+        <p:blipFill>
+          <a:blip r:embed="rId2"/>
+          <a:stretch>
+            <a:fillRect/>
+          </a:stretch>
+        </p:blipFill>
+        <p:spPr>
+          <a:xfrm>
+            <a:off x="5326705" y="0"/>
+            <a:ext cx="6865295" cy="6858000"/>
+          </a:xfrm>
+          <a:prstGeom prst="rect">
+            <a:avLst/>
+          </a:prstGeom>
+        </p:spPr>
+      </p:pic>
+    </p:spTree>
+    <p:extLst>
+      <p:ext uri="{BB962C8B-B14F-4D97-AF65-F5344CB8AC3E}">
+        <p14:creationId xmlns:p14="http://schemas.microsoft.com/office/powerpoint/2010/main" val="2115976206"/>
+      </p:ext>
+    </p:extLst>
+  </p:cSld>
+  <p:clrMapOvr>
+    <a:masterClrMapping/>
+  </p:clrMapOvr>
+</p:sld>
+</file>
+
+<file path=ppt/slides/slide12.xml><?xml version="1.0" encoding="utf-8"?>
+<p:sld xmlns:a="http://schemas.openxmlformats.org/drawingml/2006/main" xmlns:r="http://schemas.openxmlformats.org/officeDocument/2006/relationships" xmlns:p="http://schemas.openxmlformats.org/presentationml/2006/main">
+  <p:cSld>
+    <p:spTree>
+      <p:nvGrpSpPr>
+        <p:cNvPr id="1" name="">
+          <a:extLst>
+            <a:ext uri="{FF2B5EF4-FFF2-40B4-BE49-F238E27FC236}">
+              <a16:creationId xmlns:a16="http://schemas.microsoft.com/office/drawing/2014/main" id="{72279EF5-03CE-33C1-662F-5CBDF381A080}"/>
+            </a:ext>
+          </a:extLst>
+        </p:cNvPr>
+        <p:cNvGrpSpPr/>
+        <p:nvPr/>
+      </p:nvGrpSpPr>
+      <p:grpSpPr>
+        <a:xfrm>
+          <a:off x="0" y="0"/>
+          <a:ext cx="0" cy="0"/>
+          <a:chOff x="0" y="0"/>
+          <a:chExt cx="0" cy="0"/>
+        </a:xfrm>
+      </p:grpSpPr>
+      <p:sp>
+        <p:nvSpPr>
+          <p:cNvPr id="9" name="TextBox 8">
+            <a:extLst>
+              <a:ext uri="{FF2B5EF4-FFF2-40B4-BE49-F238E27FC236}">
+                <a16:creationId xmlns:a16="http://schemas.microsoft.com/office/drawing/2014/main" id="{8575D5C1-E355-5A5B-F9AF-D74A6667A6CB}"/>
+              </a:ext>
+            </a:extLst>
+          </p:cNvPr>
+          <p:cNvSpPr txBox="1"/>
+          <p:nvPr/>
+        </p:nvSpPr>
+        <p:spPr>
+          <a:xfrm>
+            <a:off x="7532261" y="1460802"/>
+            <a:ext cx="5255839" cy="10895290"/>
+          </a:xfrm>
+          <a:prstGeom prst="rect">
+            <a:avLst/>
+          </a:prstGeom>
+          <a:noFill/>
+        </p:spPr>
+        <p:txBody>
+          <a:bodyPr wrap="square">
+            <a:spAutoFit/>
+          </a:bodyPr>
+          <a:lstStyle/>
+          <a:p>
+            <a:r>
+              <a:rPr lang="hy-AM" sz="3200" dirty="0">
+                <a:solidFill>
+                  <a:schemeClr val="bg1"/>
+                </a:solidFill>
+              </a:rPr>
+              <a:t>Գնորդի հայցերը</a:t>
+            </a:r>
+            <a:br>
+              <a:rPr lang="hy-AM" sz="2000" dirty="0">
+                <a:solidFill>
+                  <a:schemeClr val="bg1"/>
+                </a:solidFill>
+              </a:rPr>
+            </a:br>
+            <a:br>
+              <a:rPr lang="hy-AM" sz="2000" dirty="0">
+                <a:solidFill>
+                  <a:schemeClr val="bg1"/>
+                </a:solidFill>
+              </a:rPr>
+            </a:br>
+            <a:br>
+              <a:rPr lang="hy-AM" dirty="0">
+                <a:solidFill>
+                  <a:schemeClr val="bg1"/>
+                </a:solidFill>
+              </a:rPr>
+            </a:br>
+            <a:endParaRPr lang="hy-AM" dirty="0">
+              <a:solidFill>
+                <a:schemeClr val="bg1"/>
+              </a:solidFill>
+            </a:endParaRPr>
+          </a:p>
+          <a:p>
+            <a:r>
+              <a:rPr lang="en-US" sz="2400" dirty="0">
+                <a:solidFill>
+                  <a:schemeClr val="bg1"/>
+                </a:solidFill>
+              </a:rPr>
+              <a:t>• </a:t>
+            </a:r>
+            <a:r>
+              <a:rPr lang="hy-AM" sz="2400" dirty="0">
+                <a:solidFill>
+                  <a:schemeClr val="bg1"/>
+                </a:solidFill>
+              </a:rPr>
+              <a:t>Որ վաճառողին են ուղղված</a:t>
+            </a:r>
+          </a:p>
+          <a:p>
+            <a:endParaRPr lang="hy-AM" sz="2400" dirty="0">
+              <a:solidFill>
+                <a:schemeClr val="bg1"/>
+              </a:solidFill>
+            </a:endParaRPr>
+          </a:p>
+          <a:p>
+            <a:r>
+              <a:rPr lang="en-US" sz="2400" dirty="0">
+                <a:solidFill>
+                  <a:schemeClr val="bg1"/>
+                </a:solidFill>
+              </a:rPr>
+              <a:t>•</a:t>
+            </a:r>
+            <a:r>
+              <a:rPr lang="hy-AM" sz="2400" dirty="0">
+                <a:solidFill>
+                  <a:schemeClr val="bg1"/>
+                </a:solidFill>
+              </a:rPr>
+              <a:t> Ավտոմեքենայի անունը</a:t>
+            </a:r>
+            <a:br>
+              <a:rPr lang="hy-AM" sz="2400" dirty="0">
+                <a:solidFill>
+                  <a:schemeClr val="bg1"/>
+                </a:solidFill>
+              </a:rPr>
+            </a:br>
+            <a:br>
+              <a:rPr lang="hy-AM" sz="2400" dirty="0">
+                <a:solidFill>
+                  <a:schemeClr val="bg1"/>
+                </a:solidFill>
+              </a:rPr>
+            </a:br>
+            <a:r>
+              <a:rPr lang="en-US" sz="2400" dirty="0">
+                <a:solidFill>
+                  <a:schemeClr val="bg1"/>
+                </a:solidFill>
+              </a:rPr>
+              <a:t>•</a:t>
+            </a:r>
+            <a:r>
+              <a:rPr lang="hy-AM" sz="2400" dirty="0">
+                <a:solidFill>
+                  <a:schemeClr val="bg1"/>
+                </a:solidFill>
+              </a:rPr>
+              <a:t> Տարածքը</a:t>
+            </a:r>
+            <a:br>
+              <a:rPr lang="hy-AM" sz="2400" dirty="0">
+                <a:solidFill>
+                  <a:schemeClr val="bg1"/>
+                </a:solidFill>
+              </a:rPr>
+            </a:br>
+            <a:br>
+              <a:rPr lang="hy-AM" sz="2400" dirty="0">
+                <a:solidFill>
+                  <a:schemeClr val="bg1"/>
+                </a:solidFill>
+              </a:rPr>
+            </a:br>
+            <a:r>
+              <a:rPr lang="en-US" sz="2400" dirty="0">
+                <a:solidFill>
+                  <a:schemeClr val="bg1"/>
+                </a:solidFill>
+              </a:rPr>
+              <a:t>•</a:t>
+            </a:r>
+            <a:r>
+              <a:rPr lang="hy-AM" sz="2400" dirty="0">
+                <a:solidFill>
+                  <a:schemeClr val="bg1"/>
+                </a:solidFill>
+              </a:rPr>
+              <a:t> Հայցի ուղարկման տարեթիվը</a:t>
+            </a:r>
+            <a:br>
+              <a:rPr lang="hy-AM" sz="2400" dirty="0">
+                <a:solidFill>
+                  <a:schemeClr val="bg1"/>
+                </a:solidFill>
+              </a:rPr>
+            </a:br>
+            <a:br>
+              <a:rPr lang="hy-AM" sz="2400" dirty="0">
+                <a:solidFill>
+                  <a:schemeClr val="bg1"/>
+                </a:solidFill>
+              </a:rPr>
+            </a:br>
+            <a:r>
+              <a:rPr lang="en-US" sz="2400" dirty="0">
+                <a:solidFill>
+                  <a:schemeClr val="bg1"/>
+                </a:solidFill>
+              </a:rPr>
+              <a:t>•</a:t>
+            </a:r>
+            <a:r>
+              <a:rPr lang="hy-AM" sz="2400" dirty="0">
+                <a:solidFill>
+                  <a:schemeClr val="bg1"/>
+                </a:solidFill>
+              </a:rPr>
+              <a:t> Կարգավիճակը</a:t>
+            </a:r>
+            <a:br>
+              <a:rPr lang="hy-AM" dirty="0">
+                <a:solidFill>
+                  <a:schemeClr val="bg1"/>
+                </a:solidFill>
+              </a:rPr>
+            </a:br>
+            <a:br>
+              <a:rPr lang="hy-AM" dirty="0">
+                <a:solidFill>
+                  <a:schemeClr val="bg1"/>
+                </a:solidFill>
+              </a:rPr>
+            </a:br>
+            <a:br>
+              <a:rPr lang="hy-AM" dirty="0">
+                <a:solidFill>
+                  <a:schemeClr val="bg1"/>
+                </a:solidFill>
+              </a:rPr>
+            </a:br>
+            <a:endParaRPr lang="hy-AM" dirty="0">
+              <a:solidFill>
+                <a:schemeClr val="bg1"/>
+              </a:solidFill>
+            </a:endParaRPr>
+          </a:p>
+          <a:p>
+            <a:endParaRPr lang="hy-AM" dirty="0">
+              <a:solidFill>
+                <a:schemeClr val="bg1"/>
+              </a:solidFill>
+            </a:endParaRPr>
+          </a:p>
+          <a:p>
+            <a:endParaRPr lang="hy-AM" dirty="0">
+              <a:solidFill>
+                <a:schemeClr val="bg1"/>
+              </a:solidFill>
+            </a:endParaRPr>
+          </a:p>
+          <a:p>
+            <a:endParaRPr lang="hy-AM" dirty="0">
+              <a:solidFill>
+                <a:schemeClr val="bg1"/>
+              </a:solidFill>
+            </a:endParaRPr>
+          </a:p>
+          <a:p>
+            <a:endParaRPr lang="hy-AM" dirty="0">
+              <a:solidFill>
+                <a:schemeClr val="bg1"/>
+              </a:solidFill>
+            </a:endParaRPr>
+          </a:p>
+          <a:p>
+            <a:endParaRPr lang="hy-AM" dirty="0">
+              <a:solidFill>
+                <a:schemeClr val="bg1"/>
+              </a:solidFill>
+            </a:endParaRPr>
+          </a:p>
+          <a:p>
+            <a:endParaRPr lang="hy-AM" dirty="0">
+              <a:solidFill>
+                <a:schemeClr val="bg1"/>
+              </a:solidFill>
+            </a:endParaRPr>
+          </a:p>
+          <a:p>
+            <a:endParaRPr lang="hy-AM" dirty="0">
+              <a:solidFill>
+                <a:schemeClr val="bg1"/>
+              </a:solidFill>
+            </a:endParaRPr>
+          </a:p>
+          <a:p>
+            <a:endParaRPr lang="hy-AM" dirty="0">
+              <a:solidFill>
+                <a:schemeClr val="bg1"/>
+              </a:solidFill>
+            </a:endParaRPr>
+          </a:p>
+          <a:p>
+            <a:endParaRPr lang="hy-AM" dirty="0">
+              <a:solidFill>
+                <a:schemeClr val="bg1"/>
+              </a:solidFill>
+            </a:endParaRPr>
+          </a:p>
+          <a:p>
+            <a:endParaRPr lang="hy-AM" dirty="0">
+              <a:solidFill>
+                <a:schemeClr val="bg1"/>
+              </a:solidFill>
+            </a:endParaRPr>
+          </a:p>
+          <a:p>
+            <a:endParaRPr lang="hy-AM" dirty="0">
+              <a:solidFill>
+                <a:schemeClr val="bg1"/>
+              </a:solidFill>
+            </a:endParaRPr>
+          </a:p>
+          <a:p>
+            <a:endParaRPr lang="hy-AM" dirty="0">
+              <a:solidFill>
+                <a:schemeClr val="bg1"/>
+              </a:solidFill>
+            </a:endParaRPr>
+          </a:p>
+          <a:p>
+            <a:endParaRPr lang="hy-AM" dirty="0">
+              <a:solidFill>
+                <a:schemeClr val="bg1"/>
+              </a:solidFill>
+            </a:endParaRPr>
+          </a:p>
+          <a:p>
+            <a:endParaRPr lang="hy-AM" dirty="0">
+              <a:solidFill>
+                <a:schemeClr val="bg1"/>
+              </a:solidFill>
+            </a:endParaRPr>
+          </a:p>
+          <a:p>
+            <a:endParaRPr lang="hy-AM" dirty="0">
+              <a:solidFill>
+                <a:schemeClr val="bg1"/>
+              </a:solidFill>
+            </a:endParaRPr>
+          </a:p>
+          <a:p>
+            <a:endParaRPr lang="hy-AM" dirty="0">
+              <a:solidFill>
+                <a:schemeClr val="bg1"/>
+              </a:solidFill>
+            </a:endParaRPr>
+          </a:p>
+          <a:p>
+            <a:endParaRPr lang="hy-AM" dirty="0">
+              <a:solidFill>
+                <a:schemeClr val="bg1"/>
+              </a:solidFill>
+            </a:endParaRPr>
+          </a:p>
+          <a:p>
+            <a:endParaRPr lang="en-US" dirty="0">
+              <a:solidFill>
+                <a:schemeClr val="bg1"/>
+              </a:solidFill>
+            </a:endParaRPr>
+          </a:p>
+        </p:txBody>
+      </p:sp>
+      <p:pic>
+        <p:nvPicPr>
+          <p:cNvPr id="11" name="Picture 10">
+            <a:extLst>
+              <a:ext uri="{FF2B5EF4-FFF2-40B4-BE49-F238E27FC236}">
+                <a16:creationId xmlns:a16="http://schemas.microsoft.com/office/drawing/2014/main" id="{87084A8C-790B-597A-50E4-2FE110C99D64}"/>
+              </a:ext>
+            </a:extLst>
+          </p:cNvPr>
+          <p:cNvPicPr>
+            <a:picLocks noChangeAspect="1"/>
+          </p:cNvPicPr>
+          <p:nvPr/>
+        </p:nvPicPr>
+        <p:blipFill>
+          <a:blip r:embed="rId2"/>
+          <a:stretch>
+            <a:fillRect/>
+          </a:stretch>
+        </p:blipFill>
+        <p:spPr>
+          <a:xfrm>
+            <a:off x="438912" y="1472184"/>
+            <a:ext cx="6837011" cy="5385816"/>
+          </a:xfrm>
+          <a:prstGeom prst="rect">
+            <a:avLst/>
+          </a:prstGeom>
+        </p:spPr>
+      </p:pic>
+      <p:sp>
+        <p:nvSpPr>
+          <p:cNvPr id="12" name="TextBox 11">
+            <a:extLst>
+              <a:ext uri="{FF2B5EF4-FFF2-40B4-BE49-F238E27FC236}">
+                <a16:creationId xmlns:a16="http://schemas.microsoft.com/office/drawing/2014/main" id="{6AC8CD3A-82D0-C7D2-70DD-80DD26E9F6F0}"/>
+              </a:ext>
+            </a:extLst>
+          </p:cNvPr>
+          <p:cNvSpPr txBox="1"/>
+          <p:nvPr/>
+        </p:nvSpPr>
+        <p:spPr>
+          <a:xfrm>
+            <a:off x="438912" y="525876"/>
+            <a:ext cx="6126480" cy="923330"/>
+          </a:xfrm>
+          <a:prstGeom prst="rect">
+            <a:avLst/>
+          </a:prstGeom>
+          <a:noFill/>
+        </p:spPr>
+        <p:txBody>
+          <a:bodyPr wrap="square" rtlCol="0">
+            <a:spAutoFit/>
+          </a:bodyPr>
+          <a:lstStyle/>
+          <a:p>
+            <a:r>
+              <a:rPr lang="hy-AM" sz="3600" dirty="0">
+                <a:solidFill>
+                  <a:schemeClr val="bg1"/>
+                </a:solidFill>
+              </a:rPr>
+              <a:t>Գնորդի հայցերի էջ</a:t>
+            </a:r>
+          </a:p>
+          <a:p>
+            <a:endParaRPr lang="en-US" dirty="0"/>
+          </a:p>
+        </p:txBody>
+      </p:sp>
+    </p:spTree>
+    <p:extLst>
+      <p:ext uri="{BB962C8B-B14F-4D97-AF65-F5344CB8AC3E}">
+        <p14:creationId xmlns:p14="http://schemas.microsoft.com/office/powerpoint/2010/main" val="2100715837"/>
+      </p:ext>
+    </p:extLst>
+  </p:cSld>
+  <p:clrMapOvr>
+    <a:masterClrMapping/>
+  </p:clrMapOvr>
+</p:sld>
+</file>
+
+<file path=ppt/slides/slide13.xml><?xml version="1.0" encoding="utf-8"?>
+<p:sld xmlns:a="http://schemas.openxmlformats.org/drawingml/2006/main" xmlns:r="http://schemas.openxmlformats.org/officeDocument/2006/relationships" xmlns:p="http://schemas.openxmlformats.org/presentationml/2006/main">
+  <p:cSld>
+    <p:spTree>
+      <p:nvGrpSpPr>
+        <p:cNvPr id="1" name="">
+          <a:extLst>
+            <a:ext uri="{FF2B5EF4-FFF2-40B4-BE49-F238E27FC236}">
+              <a16:creationId xmlns:a16="http://schemas.microsoft.com/office/drawing/2014/main" id="{1932F2CA-5A42-3D54-F2F0-B2DD96D2C085}"/>
+            </a:ext>
+          </a:extLst>
+        </p:cNvPr>
+        <p:cNvGrpSpPr/>
+        <p:nvPr/>
+      </p:nvGrpSpPr>
+      <p:grpSpPr>
+        <a:xfrm>
+          <a:off x="0" y="0"/>
+          <a:ext cx="0" cy="0"/>
+          <a:chOff x="0" y="0"/>
+          <a:chExt cx="0" cy="0"/>
+        </a:xfrm>
+      </p:grpSpPr>
+      <p:sp>
+        <p:nvSpPr>
+          <p:cNvPr id="9" name="TextBox 8">
+            <a:extLst>
+              <a:ext uri="{FF2B5EF4-FFF2-40B4-BE49-F238E27FC236}">
+                <a16:creationId xmlns:a16="http://schemas.microsoft.com/office/drawing/2014/main" id="{6108C74B-92D8-0180-5FCE-37FE0B530785}"/>
+              </a:ext>
+            </a:extLst>
+          </p:cNvPr>
+          <p:cNvSpPr txBox="1"/>
+          <p:nvPr/>
+        </p:nvSpPr>
+        <p:spPr>
+          <a:xfrm>
+            <a:off x="5284145" y="104334"/>
+            <a:ext cx="6907855" cy="8679299"/>
+          </a:xfrm>
+          <a:prstGeom prst="rect">
+            <a:avLst/>
+          </a:prstGeom>
+          <a:noFill/>
+        </p:spPr>
+        <p:txBody>
+          <a:bodyPr wrap="square">
+            <a:spAutoFit/>
+          </a:bodyPr>
+          <a:lstStyle/>
+          <a:p>
+            <a:endParaRPr lang="hy-AM" dirty="0">
+              <a:solidFill>
+                <a:schemeClr val="bg1"/>
+              </a:solidFill>
+            </a:endParaRPr>
+          </a:p>
+          <a:p>
+            <a:r>
+              <a:rPr lang="en-US" sz="2400" dirty="0">
+                <a:solidFill>
+                  <a:schemeClr val="bg1"/>
+                </a:solidFill>
+              </a:rPr>
+              <a:t>• </a:t>
+            </a:r>
+            <a:r>
+              <a:rPr lang="hy-AM" sz="2400" dirty="0">
+                <a:solidFill>
+                  <a:schemeClr val="bg1"/>
+                </a:solidFill>
+              </a:rPr>
+              <a:t>Ավտոմեքենայի հայտարարության ավելացում</a:t>
+            </a:r>
+          </a:p>
+          <a:p>
+            <a:endParaRPr lang="hy-AM" sz="2400" dirty="0">
+              <a:solidFill>
+                <a:schemeClr val="bg1"/>
+              </a:solidFill>
+            </a:endParaRPr>
+          </a:p>
+          <a:p>
+            <a:r>
+              <a:rPr lang="en-US" sz="2400" dirty="0">
+                <a:solidFill>
+                  <a:schemeClr val="bg1"/>
+                </a:solidFill>
+              </a:rPr>
+              <a:t>•</a:t>
+            </a:r>
+            <a:r>
+              <a:rPr lang="hy-AM" sz="2400" dirty="0">
+                <a:solidFill>
+                  <a:schemeClr val="bg1"/>
+                </a:solidFill>
+              </a:rPr>
+              <a:t> Հայտարարությունների կազմակերպում</a:t>
+            </a:r>
+            <a:br>
+              <a:rPr lang="hy-AM" sz="2400" dirty="0">
+                <a:solidFill>
+                  <a:schemeClr val="bg1"/>
+                </a:solidFill>
+              </a:rPr>
+            </a:br>
+            <a:br>
+              <a:rPr lang="hy-AM" sz="2400" dirty="0">
+                <a:solidFill>
+                  <a:schemeClr val="bg1"/>
+                </a:solidFill>
+              </a:rPr>
+            </a:br>
+            <a:r>
+              <a:rPr lang="en-US" sz="2400" dirty="0">
+                <a:solidFill>
+                  <a:schemeClr val="bg1"/>
+                </a:solidFill>
+              </a:rPr>
+              <a:t>•</a:t>
+            </a:r>
+            <a:r>
+              <a:rPr lang="hy-AM" sz="2400" dirty="0">
+                <a:solidFill>
+                  <a:schemeClr val="bg1"/>
+                </a:solidFill>
+              </a:rPr>
+              <a:t> Հայցերի կազմակերպում</a:t>
+            </a:r>
+            <a:br>
+              <a:rPr lang="hy-AM" sz="2400" dirty="0">
+                <a:solidFill>
+                  <a:schemeClr val="bg1"/>
+                </a:solidFill>
+              </a:rPr>
+            </a:br>
+            <a:br>
+              <a:rPr lang="hy-AM" sz="2400" dirty="0">
+                <a:solidFill>
+                  <a:schemeClr val="bg1"/>
+                </a:solidFill>
+              </a:rPr>
+            </a:br>
+            <a:br>
+              <a:rPr lang="hy-AM" dirty="0">
+                <a:solidFill>
+                  <a:schemeClr val="bg1"/>
+                </a:solidFill>
+              </a:rPr>
+            </a:br>
+            <a:br>
+              <a:rPr lang="hy-AM" dirty="0">
+                <a:solidFill>
+                  <a:schemeClr val="bg1"/>
+                </a:solidFill>
+              </a:rPr>
+            </a:br>
+            <a:br>
+              <a:rPr lang="hy-AM" dirty="0">
+                <a:solidFill>
+                  <a:schemeClr val="bg1"/>
+                </a:solidFill>
+              </a:rPr>
+            </a:br>
+            <a:endParaRPr lang="hy-AM" dirty="0">
+              <a:solidFill>
+                <a:schemeClr val="bg1"/>
+              </a:solidFill>
+            </a:endParaRPr>
+          </a:p>
+          <a:p>
+            <a:endParaRPr lang="hy-AM" dirty="0">
+              <a:solidFill>
+                <a:schemeClr val="bg1"/>
+              </a:solidFill>
+            </a:endParaRPr>
+          </a:p>
+          <a:p>
+            <a:endParaRPr lang="hy-AM" dirty="0">
+              <a:solidFill>
+                <a:schemeClr val="bg1"/>
+              </a:solidFill>
+            </a:endParaRPr>
+          </a:p>
+          <a:p>
+            <a:endParaRPr lang="hy-AM" dirty="0">
+              <a:solidFill>
+                <a:schemeClr val="bg1"/>
+              </a:solidFill>
+            </a:endParaRPr>
+          </a:p>
+          <a:p>
+            <a:endParaRPr lang="hy-AM" dirty="0">
+              <a:solidFill>
+                <a:schemeClr val="bg1"/>
+              </a:solidFill>
+            </a:endParaRPr>
+          </a:p>
+          <a:p>
+            <a:endParaRPr lang="hy-AM" dirty="0">
+              <a:solidFill>
+                <a:schemeClr val="bg1"/>
+              </a:solidFill>
+            </a:endParaRPr>
+          </a:p>
+          <a:p>
+            <a:endParaRPr lang="hy-AM" dirty="0">
+              <a:solidFill>
+                <a:schemeClr val="bg1"/>
+              </a:solidFill>
+            </a:endParaRPr>
+          </a:p>
+          <a:p>
+            <a:endParaRPr lang="hy-AM" dirty="0">
+              <a:solidFill>
+                <a:schemeClr val="bg1"/>
+              </a:solidFill>
+            </a:endParaRPr>
+          </a:p>
+          <a:p>
+            <a:endParaRPr lang="hy-AM" dirty="0">
+              <a:solidFill>
+                <a:schemeClr val="bg1"/>
+              </a:solidFill>
+            </a:endParaRPr>
+          </a:p>
+          <a:p>
+            <a:endParaRPr lang="hy-AM" dirty="0">
+              <a:solidFill>
+                <a:schemeClr val="bg1"/>
+              </a:solidFill>
+            </a:endParaRPr>
+          </a:p>
+          <a:p>
+            <a:endParaRPr lang="hy-AM" dirty="0">
+              <a:solidFill>
+                <a:schemeClr val="bg1"/>
+              </a:solidFill>
+            </a:endParaRPr>
+          </a:p>
+          <a:p>
+            <a:endParaRPr lang="hy-AM" dirty="0">
+              <a:solidFill>
+                <a:schemeClr val="bg1"/>
+              </a:solidFill>
+            </a:endParaRPr>
+          </a:p>
+          <a:p>
+            <a:endParaRPr lang="hy-AM" dirty="0">
+              <a:solidFill>
+                <a:schemeClr val="bg1"/>
+              </a:solidFill>
+            </a:endParaRPr>
+          </a:p>
+          <a:p>
+            <a:endParaRPr lang="hy-AM" dirty="0">
+              <a:solidFill>
+                <a:schemeClr val="bg1"/>
+              </a:solidFill>
+            </a:endParaRPr>
+          </a:p>
+          <a:p>
+            <a:endParaRPr lang="hy-AM" dirty="0">
+              <a:solidFill>
+                <a:schemeClr val="bg1"/>
+              </a:solidFill>
+            </a:endParaRPr>
+          </a:p>
+          <a:p>
+            <a:endParaRPr lang="hy-AM" dirty="0">
+              <a:solidFill>
+                <a:schemeClr val="bg1"/>
+              </a:solidFill>
+            </a:endParaRPr>
+          </a:p>
+          <a:p>
+            <a:endParaRPr lang="hy-AM" dirty="0">
+              <a:solidFill>
+                <a:schemeClr val="bg1"/>
+              </a:solidFill>
+            </a:endParaRPr>
+          </a:p>
+          <a:p>
+            <a:endParaRPr lang="hy-AM" dirty="0">
+              <a:solidFill>
+                <a:schemeClr val="bg1"/>
+              </a:solidFill>
+            </a:endParaRPr>
+          </a:p>
+          <a:p>
+            <a:endParaRPr lang="en-US" dirty="0">
+              <a:solidFill>
+                <a:schemeClr val="bg1"/>
+              </a:solidFill>
+            </a:endParaRPr>
+          </a:p>
+        </p:txBody>
+      </p:sp>
+      <p:sp>
+        <p:nvSpPr>
+          <p:cNvPr id="12" name="TextBox 11">
+            <a:extLst>
+              <a:ext uri="{FF2B5EF4-FFF2-40B4-BE49-F238E27FC236}">
+                <a16:creationId xmlns:a16="http://schemas.microsoft.com/office/drawing/2014/main" id="{ECB1D2FC-4F1B-014A-DA4D-B49FEF5C7554}"/>
+              </a:ext>
+            </a:extLst>
+          </p:cNvPr>
+          <p:cNvSpPr txBox="1"/>
+          <p:nvPr/>
+        </p:nvSpPr>
+        <p:spPr>
+          <a:xfrm>
+            <a:off x="-30480" y="188410"/>
+            <a:ext cx="6126480" cy="923330"/>
+          </a:xfrm>
+          <a:prstGeom prst="rect">
+            <a:avLst/>
+          </a:prstGeom>
+          <a:noFill/>
+        </p:spPr>
+        <p:txBody>
+          <a:bodyPr wrap="square" rtlCol="0">
+            <a:spAutoFit/>
+          </a:bodyPr>
+          <a:lstStyle/>
+          <a:p>
+            <a:r>
+              <a:rPr lang="hy-AM" sz="3600" dirty="0">
+                <a:solidFill>
+                  <a:schemeClr val="bg1"/>
+                </a:solidFill>
+              </a:rPr>
+              <a:t>Վաճառողի վահանակ</a:t>
+            </a:r>
+          </a:p>
+          <a:p>
+            <a:endParaRPr lang="en-US" dirty="0"/>
+          </a:p>
+        </p:txBody>
+      </p:sp>
+      <p:pic>
+        <p:nvPicPr>
+          <p:cNvPr id="3" name="Picture 2">
+            <a:extLst>
+              <a:ext uri="{FF2B5EF4-FFF2-40B4-BE49-F238E27FC236}">
+                <a16:creationId xmlns:a16="http://schemas.microsoft.com/office/drawing/2014/main" id="{38CE0B37-2A7F-0F2C-1511-B005228433DD}"/>
+              </a:ext>
+            </a:extLst>
+          </p:cNvPr>
+          <p:cNvPicPr>
+            <a:picLocks noChangeAspect="1"/>
+          </p:cNvPicPr>
+          <p:nvPr/>
+        </p:nvPicPr>
+        <p:blipFill>
+          <a:blip r:embed="rId2"/>
+          <a:stretch>
+            <a:fillRect/>
+          </a:stretch>
+        </p:blipFill>
+        <p:spPr>
+          <a:xfrm>
+            <a:off x="0" y="2029968"/>
+            <a:ext cx="3548916" cy="4828032"/>
+          </a:xfrm>
+          <a:prstGeom prst="rect">
+            <a:avLst/>
+          </a:prstGeom>
+        </p:spPr>
+      </p:pic>
+      <p:pic>
+        <p:nvPicPr>
+          <p:cNvPr id="10" name="Picture 9">
+            <a:extLst>
+              <a:ext uri="{FF2B5EF4-FFF2-40B4-BE49-F238E27FC236}">
+                <a16:creationId xmlns:a16="http://schemas.microsoft.com/office/drawing/2014/main" id="{740DB87F-1017-E606-3CBD-D2F71D28D58E}"/>
+              </a:ext>
+            </a:extLst>
+          </p:cNvPr>
+          <p:cNvPicPr>
+            <a:picLocks noChangeAspect="1"/>
+          </p:cNvPicPr>
+          <p:nvPr/>
+        </p:nvPicPr>
+        <p:blipFill>
+          <a:blip r:embed="rId3"/>
+          <a:stretch>
+            <a:fillRect/>
+          </a:stretch>
+        </p:blipFill>
+        <p:spPr>
+          <a:xfrm>
+            <a:off x="4548658" y="3147521"/>
+            <a:ext cx="7643342" cy="2592921"/>
+          </a:xfrm>
+          <a:prstGeom prst="rect">
+            <a:avLst/>
+          </a:prstGeom>
+        </p:spPr>
+      </p:pic>
+      <p:pic>
+        <p:nvPicPr>
+          <p:cNvPr id="14" name="Picture 13">
+            <a:extLst>
+              <a:ext uri="{FF2B5EF4-FFF2-40B4-BE49-F238E27FC236}">
+                <a16:creationId xmlns:a16="http://schemas.microsoft.com/office/drawing/2014/main" id="{5934A6D6-83FB-87E4-8FA5-0ED42C363017}"/>
+              </a:ext>
+            </a:extLst>
+          </p:cNvPr>
+          <p:cNvPicPr>
+            <a:picLocks noChangeAspect="1"/>
+          </p:cNvPicPr>
+          <p:nvPr/>
+        </p:nvPicPr>
+        <p:blipFill>
+          <a:blip r:embed="rId4"/>
+          <a:stretch>
+            <a:fillRect/>
+          </a:stretch>
+        </p:blipFill>
+        <p:spPr>
+          <a:xfrm>
+            <a:off x="6581592" y="4443982"/>
+            <a:ext cx="7345637" cy="2453649"/>
+          </a:xfrm>
+          <a:prstGeom prst="rect">
+            <a:avLst/>
+          </a:prstGeom>
+        </p:spPr>
+      </p:pic>
+    </p:spTree>
+    <p:extLst>
+      <p:ext uri="{BB962C8B-B14F-4D97-AF65-F5344CB8AC3E}">
+        <p14:creationId xmlns:p14="http://schemas.microsoft.com/office/powerpoint/2010/main" val="3201344456"/>
+      </p:ext>
+    </p:extLst>
+  </p:cSld>
+  <p:clrMapOvr>
+    <a:masterClrMapping/>
+  </p:clrMapOvr>
+</p:sld>
+</file>
+
+<file path=ppt/slides/slide14.xml><?xml version="1.0" encoding="utf-8"?>
+<p:sld xmlns:a="http://schemas.openxmlformats.org/drawingml/2006/main" xmlns:r="http://schemas.openxmlformats.org/officeDocument/2006/relationships" xmlns:p="http://schemas.openxmlformats.org/presentationml/2006/main">
+  <p:cSld>
+    <p:spTree>
+      <p:nvGrpSpPr>
+        <p:cNvPr id="1" name="">
+          <a:extLst>
+            <a:ext uri="{FF2B5EF4-FFF2-40B4-BE49-F238E27FC236}">
               <a16:creationId xmlns:a16="http://schemas.microsoft.com/office/drawing/2014/main" id="{7F34FB62-7C7D-F013-B272-7549D4D7E10A}"/>
             </a:ext>
           </a:extLst>
@@ -4116,10 +5921,10 @@
           <p:nvPr/>
         </p:nvPicPr>
         <p:blipFill>
-          <a:blip r:embed="rId3">
+          <a:blip>
             <a:extLst>
               <a:ext uri="{96DAC541-7B7A-43D3-8B79-37D633B846F1}">
-                <asvg:svgBlip xmlns:asvg="http://schemas.microsoft.com/office/drawing/2016/SVG/main" r:embed="rId4"/>
+                <asvg:svgBlip xmlns:asvg="http://schemas.microsoft.com/office/drawing/2016/SVG/main" r:embed="rId3"/>
               </a:ext>
             </a:extLst>
           </a:blip>
@@ -4302,18 +6107,26 @@
         </p:spPr>
         <p:txBody>
           <a:bodyPr>
-            <a:normAutofit/>
+            <a:normAutofit lnSpcReduction="10000"/>
           </a:bodyPr>
           <a:lstStyle/>
           <a:p>
             <a:pPr algn="l"/>
             <a:r>
+              <a:rPr lang="en-US" dirty="0">
+                <a:solidFill>
+                  <a:schemeClr val="bg1"/>
+                </a:solidFill>
+              </a:rPr>
+              <a:t>Full-stack</a:t>
+            </a:r>
+            <a:r>
               <a:rPr lang="hy-AM" dirty="0">
                 <a:solidFill>
                   <a:schemeClr val="bg1"/>
                 </a:solidFill>
               </a:rPr>
-              <a:t> Կխոսեմ </a:t>
+              <a:t> վեբ հավելվածները բաղկացած են 2 հիմնական մասերից՝ </a:t>
             </a:r>
             <a:r>
               <a:rPr lang="en-US" dirty="0">
@@ -4321,7 +6134,7 @@
                   <a:schemeClr val="bg1"/>
                 </a:solidFill>
               </a:rPr>
-              <a:t>full-stack</a:t>
+              <a:t>client</a:t>
             </a:r>
             <a:r>
               <a:rPr lang="hy-AM" dirty="0">
@@ -4329,7 +6142,7 @@
                   <a:schemeClr val="bg1"/>
                 </a:solidFill>
               </a:rPr>
-              <a:t> վեբ հավելվածների, դրանց հիմնական մասերի՝ </a:t>
+              <a:t> և </a:t>
             </a:r>
             <a:r>
               <a:rPr lang="en-US" dirty="0">
@@ -4337,7 +6150,7 @@
                   <a:schemeClr val="bg1"/>
                 </a:solidFill>
               </a:rPr>
-              <a:t>client</a:t>
+              <a:t>server</a:t>
             </a:r>
             <a:r>
               <a:rPr lang="hy-AM" dirty="0">
@@ -4345,23 +6158,7 @@
                   <a:schemeClr val="bg1"/>
                 </a:solidFill>
               </a:rPr>
-              <a:t> և </a:t>
-            </a:r>
-            <a:r>
-              <a:rPr lang="en-US" dirty="0">
-                <a:solidFill>
-                  <a:schemeClr val="bg1"/>
-                </a:solidFill>
-              </a:rPr>
-              <a:t>server</a:t>
-            </a:r>
-            <a:r>
-              <a:rPr lang="hy-AM" dirty="0">
-                <a:solidFill>
-                  <a:schemeClr val="bg1"/>
-                </a:solidFill>
-              </a:rPr>
-              <a:t>, և յուրաքանչյուրի բաղադրիչների մասին։</a:t>
+              <a:t>։</a:t>
             </a:r>
             <a:br>
               <a:rPr lang="hy-AM" dirty="0">
@@ -4392,7 +6189,7 @@
                   <a:schemeClr val="bg1"/>
                 </a:solidFill>
               </a:rPr>
-              <a:t>ի մասով կխոսեմ բրաուզերների</a:t>
+              <a:t>ի հատվածում կքքնարկվի բրաուզերների աշխատանքի սկզբունքները, վեբ կայքերի կառուցվածքը և դրանց հիմնական բաղադրիչները։ </a:t>
             </a:r>
             <a:r>
               <a:rPr lang="en-US" dirty="0">
@@ -4400,7 +6197,7 @@
                   <a:schemeClr val="bg1"/>
                 </a:solidFill>
               </a:rPr>
-              <a:t>, </a:t>
+              <a:t>Server-</a:t>
             </a:r>
             <a:r>
               <a:rPr lang="hy-AM" dirty="0">
@@ -4408,7 +6205,7 @@
                   <a:schemeClr val="bg1"/>
                 </a:solidFill>
               </a:rPr>
-              <a:t>վեբ կայքերի և դրանց բաղադրիչների մասին, իսկ սերվերի մասով՝</a:t>
+              <a:t>ի հատվածում կքննարկվի սերվերի աշխատանքը և տվյալների բազաների դերը համակարգում։ Բացի այդ, կցուցադրվի </a:t>
             </a:r>
             <a:r>
               <a:rPr lang="en-US" dirty="0">
@@ -4416,7 +6213,7 @@
                   <a:schemeClr val="bg1"/>
                 </a:solidFill>
               </a:rPr>
-              <a:t> </a:t>
+              <a:t>client-server </a:t>
             </a:r>
             <a:r>
               <a:rPr lang="hy-AM" dirty="0">
@@ -4424,7 +6221,7 @@
                   <a:schemeClr val="bg1"/>
                 </a:solidFill>
               </a:rPr>
-              <a:t>սերվերի աշխատանքի և տվյալների բազաների մասին։ Նաև կցուցադրեմ, թե ինչպես են դրանք միասին աշխատում ՝ օգտվելով </a:t>
+              <a:t>համագործակցությունը՝ օգտագործելով </a:t>
             </a:r>
             <a:r>
               <a:rPr lang="en-US" dirty="0">
@@ -4432,7 +6229,7 @@
                   <a:schemeClr val="bg1"/>
                 </a:solidFill>
               </a:rPr>
-              <a:t>login-</a:t>
+              <a:t>login </a:t>
             </a:r>
             <a:r>
               <a:rPr lang="hy-AM" dirty="0">
@@ -4440,11 +6237,13 @@
                   <a:schemeClr val="bg1"/>
                 </a:solidFill>
               </a:rPr>
-              <a:t>ի օրինակից։</a:t>
-            </a:r>
-          </a:p>
-          <a:p>
-            <a:endParaRPr lang="en-US" dirty="0"/>
+              <a:t>գործընթացի օրինակը։</a:t>
+            </a:r>
+            <a:endParaRPr lang="en-US" dirty="0">
+              <a:solidFill>
+                <a:schemeClr val="bg1"/>
+              </a:solidFill>
+            </a:endParaRPr>
           </a:p>
         </p:txBody>
       </p:sp>

</xml_diff>